<commit_message>
fix index bug on LS and added verse
</commit_message>
<xml_diff>
--- a/assets/readings-supper.pptx
+++ b/assets/readings-supper.pptx
@@ -108,6 +108,7 @@
     <p:sldId id="358" r:id="rId102"/>
     <p:sldId id="359" r:id="rId103"/>
     <p:sldId id="360" r:id="rId104"/>
+    <p:sldId id="361" r:id="rId109"/>
   </p:sldIdLst>
   <p:sldSz cx="12192000" cy="6858000"/>
   <p:notesSz cx="6858000" cy="9144000"/>
@@ -2032,6 +2033,134 @@
 </p:sld>
 </file>
 
+<file path=ppt/slides/slide104.xml><?xml version="1.0" encoding="utf-8"?>
+<p:sld xmlns:a="http://schemas.openxmlformats.org/drawingml/2006/main" xmlns:p="http://schemas.openxmlformats.org/presentationml/2006/main" xmlns:r="http://schemas.openxmlformats.org/officeDocument/2006/relationships">
+  <p:cSld>
+    <p:spTree>
+      <p:nvGrpSpPr>
+        <p:cNvPr id="1" name=""/>
+        <p:cNvGrpSpPr/>
+        <p:nvPr/>
+      </p:nvGrpSpPr>
+      <p:grpSpPr/>
+      <p:sp>
+        <p:nvSpPr>
+          <p:cNvPr id="4" name="Text Placeholder 3">
+            <a:extLst>
+              <a:ext uri="{FF2B5EF4-FFF2-40B4-BE49-F238E27FC236}">
+                <a16:creationId xmlns:a16="http://schemas.microsoft.com/office/drawing/2014/main" id="{DFD9D55F-EF00-CB99-E3DF-A541273F03E7}"/>
+              </a:ext>
+            </a:extLst>
+          </p:cNvPr>
+          <p:cNvSpPr>
+            <a:spLocks noGrp="1"/>
+          </p:cNvSpPr>
+          <p:nvPr>
+            <p:ph type="body" sz="quarter" idx="10"/>
+          </p:nvPr>
+        </p:nvSpPr>
+        <p:spPr/>
+        <p:txBody>
+          <a:bodyPr/>
+          <a:lstStyle/>
+          <a:p>
+            <a:r>
+              <a:t>1 Corinthians 11:27-29</a:t>
+            </a:r>
+          </a:p>
+        </p:txBody>
+      </p:sp>
+      <p:sp>
+        <p:nvSpPr>
+          <p:cNvPr id="5" name="Text Placeholder 4">
+            <a:extLst>
+              <a:ext uri="{FF2B5EF4-FFF2-40B4-BE49-F238E27FC236}">
+                <a16:creationId xmlns:a16="http://schemas.microsoft.com/office/drawing/2014/main" id="{183C6CE0-2BF5-9A80-AAF9-98602288B00B}"/>
+              </a:ext>
+            </a:extLst>
+          </p:cNvPr>
+          <p:cNvSpPr>
+            <a:spLocks noGrp="1"/>
+          </p:cNvSpPr>
+          <p:nvPr>
+            <p:ph type="body" sz="quarter" idx="11"/>
+          </p:nvPr>
+        </p:nvSpPr>
+        <p:spPr/>
+        <p:txBody>
+          <a:bodyPr/>
+          <a:lstStyle/>
+          <a:p>
+            <a:r>
+              <a:t>1 Corintios 11:27-29</a:t>
+            </a:r>
+          </a:p>
+        </p:txBody>
+      </p:sp>
+      <p:sp>
+        <p:nvSpPr>
+          <p:cNvPr id="6" name="Text Placeholder 5">
+            <a:extLst>
+              <a:ext uri="{FF2B5EF4-FFF2-40B4-BE49-F238E27FC236}">
+                <a16:creationId xmlns:a16="http://schemas.microsoft.com/office/drawing/2014/main" id="{E3687956-5B1E-E87A-C63F-2CF83852F74A}"/>
+              </a:ext>
+            </a:extLst>
+          </p:cNvPr>
+          <p:cNvSpPr>
+            <a:spLocks noGrp="1"/>
+          </p:cNvSpPr>
+          <p:nvPr>
+            <p:ph type="body" sz="quarter" idx="12"/>
+          </p:nvPr>
+        </p:nvSpPr>
+        <p:spPr/>
+        <p:txBody>
+          <a:bodyPr/>
+          <a:lstStyle/>
+          <a:p>
+            <a:r>
+              <a:rPr sz="1800"/>
+              <a:t>Therefore whoever eats the bread or drinks the cup of the Lord in an unworthy manner, shall be guilty of the body and the blood of the Lord. But a man must examine himself, and in so doing he is to eat of the bread and drink of the cup. For he who eats and drinks, eats and drinks judgment to himself if he does not judge the body rightly.</a:t>
+            </a:r>
+          </a:p>
+        </p:txBody>
+      </p:sp>
+      <p:sp>
+        <p:nvSpPr>
+          <p:cNvPr id="7" name="Text Placeholder 6">
+            <a:extLst>
+              <a:ext uri="{FF2B5EF4-FFF2-40B4-BE49-F238E27FC236}">
+                <a16:creationId xmlns:a16="http://schemas.microsoft.com/office/drawing/2014/main" id="{939E2508-EFDC-0849-203A-1E6D24D54960}"/>
+              </a:ext>
+            </a:extLst>
+          </p:cNvPr>
+          <p:cNvSpPr>
+            <a:spLocks noGrp="1"/>
+          </p:cNvSpPr>
+          <p:nvPr>
+            <p:ph type="body" sz="quarter" idx="13"/>
+          </p:nvPr>
+        </p:nvSpPr>
+        <p:spPr/>
+        <p:txBody>
+          <a:bodyPr/>
+          <a:lstStyle/>
+          <a:p>
+            <a:r>
+              <a:rPr sz="1800"/>
+              <a:t>De manera que cualquiera que comiere este pan o bebiere esta copa del Señor indignamente, será culpado del cuerpo y de la sangre del Señor. Por tanto, pruébese cada uno a sí mismo, y coma así del pan, y beba de la copa. Porque el que come y bebe indignamente, sin discernir el cuerpo del Señor, juicio come y bebe para sí.</a:t>
+            </a:r>
+          </a:p>
+        </p:txBody>
+      </p:sp>
+    </p:spTree>
+  </p:cSld>
+  <p:clrMapOvr>
+    <a:masterClrMapping/>
+  </p:clrMapOvr>
+</p:sld>
+</file>
+
 <file path=ppt/slides/slide11.xml><?xml version="1.0" encoding="utf-8"?>
 <p:sld xmlns:a="http://schemas.openxmlformats.org/drawingml/2006/main" xmlns:r="http://schemas.openxmlformats.org/officeDocument/2006/relationships" xmlns:p="http://schemas.openxmlformats.org/presentationml/2006/main">
   <p:cSld>

</xml_diff>